<commit_message>
Refine proposal cover typography
</commit_message>
<xml_diff>
--- a/Rent-Unfiltered-計畫書封面.pptx
+++ b/Rent-Unfiltered-計畫書封面.pptx
@@ -2,13 +2,13 @@
 <file path=ppt/presentation.xml><?xml version="1.0" encoding="utf-8"?>
 <p:presentation xmlns:p="http://schemas.openxmlformats.org/presentationml/2006/main">
   <p:sldMasterIdLst>
-    <p:sldMasterId xmlns:r="http://schemas.openxmlformats.org/officeDocument/2006/relationships" id="2147483648" r:id="R93f0b8c461874129"/>
+    <p:sldMasterId xmlns:r="http://schemas.openxmlformats.org/officeDocument/2006/relationships" id="2147483648" r:id="Rc6dfb243ad264006"/>
   </p:sldMasterIdLst>
   <p:notesMasterIdLst>
-    <p:notesMasterId xmlns:r="http://schemas.openxmlformats.org/officeDocument/2006/relationships" r:id="R1311fff814ac494d"/>
+    <p:notesMasterId xmlns:r="http://schemas.openxmlformats.org/officeDocument/2006/relationships" r:id="Rd9d1a094ad9d483b"/>
   </p:notesMasterIdLst>
   <p:sldIdLst>
-    <p:sldId xmlns:r="http://schemas.openxmlformats.org/officeDocument/2006/relationships" id="256" r:id="R650f6c613ae84649"/>
+    <p:sldId xmlns:r="http://schemas.openxmlformats.org/officeDocument/2006/relationships" id="256" r:id="R639c28180ace4504"/>
   </p:sldIdLst>
   <p:sldSz cx="14630400" cy="9753600"/>
   <p:notesSz cx="6858000" cy="9144000"/>
@@ -555,7 +555,7 @@
   </p:cSld>
   <p:clrMap bg1="lt1" tx1="dk1" bg2="lt2" tx2="dk2" accent1="accent1" accent2="accent2" accent3="accent3" accent4="accent4" accent5="accent5" accent6="accent6" hlink="hlink" folHlink="folHlink"/>
   <p:sldLayoutIdLst>
-    <p:sldLayoutId xmlns:r="http://schemas.openxmlformats.org/officeDocument/2006/relationships" id="2147483649" r:id="R1a2345e1c500431d"/>
+    <p:sldLayoutId xmlns:r="http://schemas.openxmlformats.org/officeDocument/2006/relationships" id="2147483649" r:id="Raf732d1ac35b48c5"/>
   </p:sldLayoutIdLst>
   <p:txStyles>
     <p:titleStyle>
@@ -858,7 +858,7 @@
           <p:nvPr/>
         </p:nvPicPr>
         <p:blipFill>
-          <a:blip xmlns:r="http://schemas.openxmlformats.org/officeDocument/2006/relationships" xmlns:a="http://schemas.openxmlformats.org/drawingml/2006/main" r:embed="R1d0db1bcb5fb477b"/>
+          <a:blip xmlns:r="http://schemas.openxmlformats.org/officeDocument/2006/relationships" xmlns:a="http://schemas.openxmlformats.org/drawingml/2006/main" r:embed="Raa1de0ba6d6a4137"/>
           <a:srcRect xmlns:a="http://schemas.openxmlformats.org/drawingml/2006/main" l="0" t="0" r="0" b="0"/>
           <a:stretch xmlns:a="http://schemas.openxmlformats.org/drawingml/2006/main">
             <a:fillRect l="0" t="0" r="0" b="0"/>
@@ -879,7 +879,7 @@
           <p:cNvPr id="2" name="title-soft-panel">
             <a:extLst xmlns:a="http://schemas.openxmlformats.org/drawingml/2006/main">
               <a:ext uri="{FF2B5EF4-FFF2-40B4-BE49-F238E27FC236}">
-                <a16:creationId xmlns:a16="http://schemas.microsoft.com/office/drawing/2014/main" id="{44826AA2-BEAE-4293-B0C1-092F84050B23}"/>
+                <a16:creationId xmlns:a16="http://schemas.microsoft.com/office/drawing/2014/main" id="{EB42465A-F0BF-4D8B-BE6E-9669911D0FCC}"/>
               </a:ext>
             </a:extLst>
           </p:cNvPr>
@@ -890,21 +890,21 @@
         </p:nvSpPr>
         <p:spPr>
           <a:xfrm xmlns:a="http://schemas.openxmlformats.org/drawingml/2006/main">
-            <a:off x="2857500" y="342900"/>
-            <a:ext cx="8915400" cy="1752600"/>
+            <a:off x="3086100" y="323850"/>
+            <a:ext cx="8458200" cy="1714500"/>
           </a:xfrm>
           <a:prstGeom xmlns:a="http://schemas.openxmlformats.org/drawingml/2006/main" prst="rect">
             <a:avLst/>
           </a:prstGeom>
           <a:solidFill xmlns:a="http://schemas.openxmlformats.org/drawingml/2006/main">
             <a:srgbClr val="F8FBFF">
-              <a:alpha val="73333"/>
+              <a:alpha val="33333"/>
             </a:srgbClr>
           </a:solidFill>
-          <a:ln xmlns:a="http://schemas.openxmlformats.org/drawingml/2006/main" w="9525">
+          <a:ln xmlns:a="http://schemas.openxmlformats.org/drawingml/2006/main" w="4763">
             <a:solidFill>
-              <a:srgbClr val="8BB9E8">
-                <a:alpha val="33333"/>
+              <a:srgbClr val="C7DDF0">
+                <a:alpha val="20000"/>
               </a:srgbClr>
             </a:solidFill>
             <a:prstDash val="solid"/>
@@ -916,7 +916,7 @@
           <p:cNvPr id="3" name="project-title-en">
             <a:extLst xmlns:a="http://schemas.openxmlformats.org/drawingml/2006/main">
               <a:ext uri="{FF2B5EF4-FFF2-40B4-BE49-F238E27FC236}">
-                <a16:creationId xmlns:a16="http://schemas.microsoft.com/office/drawing/2014/main" id="{7084B2F3-CD29-412F-9DE4-26FF5EFC6F31}"/>
+                <a16:creationId xmlns:a16="http://schemas.microsoft.com/office/drawing/2014/main" id="{79214D05-2D40-495A-8053-32CB60DC21F7}"/>
               </a:ext>
             </a:extLst>
           </p:cNvPr>
@@ -954,7 +954,7 @@
             <a:pPr algn="ctr">
               <a:defRPr sz="2775" b="0">
                 <a:solidFill>
-                  <a:srgbClr val="264D73"/>
+                  <a:srgbClr val="244A70"/>
                 </a:solidFill>
                 <a:latin typeface="Aptos Display"/>
                 <a:ea typeface="Aptos Display"/>
@@ -964,7 +964,7 @@
             <a:r>
               <a:rPr sz="2775" b="0">
                 <a:solidFill>
-                  <a:srgbClr val="264D73"/>
+                  <a:srgbClr val="244A70"/>
                 </a:solidFill>
                 <a:latin typeface="Aptos Display"/>
                 <a:ea typeface="Aptos Display"/>
@@ -980,7 +980,7 @@
           <p:cNvPr id="4" name="project-title-zh">
             <a:extLst xmlns:a="http://schemas.openxmlformats.org/drawingml/2006/main">
               <a:ext uri="{FF2B5EF4-FFF2-40B4-BE49-F238E27FC236}">
-                <a16:creationId xmlns:a16="http://schemas.microsoft.com/office/drawing/2014/main" id="{789FD392-BF1B-44C4-8635-25977259ECE4}"/>
+                <a16:creationId xmlns:a16="http://schemas.microsoft.com/office/drawing/2014/main" id="{7E0DBF4D-E4CD-4C13-BE59-590BC0222F3C}"/>
               </a:ext>
             </a:extLst>
           </p:cNvPr>
@@ -1018,7 +1018,7 @@
             <a:pPr algn="ctr">
               <a:defRPr sz="3450" b="0">
                 <a:solidFill>
-                  <a:srgbClr val="173A5D"/>
+                  <a:srgbClr val="163755"/>
                 </a:solidFill>
                 <a:latin typeface="Microsoft JhengHei Light"/>
                 <a:ea typeface="Microsoft JhengHei Light"/>
@@ -1028,7 +1028,7 @@
             <a:r>
               <a:rPr sz="3450" b="0">
                 <a:solidFill>
-                  <a:srgbClr val="173A5D"/>
+                  <a:srgbClr val="163755"/>
                 </a:solidFill>
                 <a:latin typeface="Microsoft JhengHei Light"/>
                 <a:ea typeface="Microsoft JhengHei Light"/>
@@ -1044,7 +1044,7 @@
           <p:cNvPr id="5" name="cover-slogan">
             <a:extLst xmlns:a="http://schemas.openxmlformats.org/drawingml/2006/main">
               <a:ext uri="{FF2B5EF4-FFF2-40B4-BE49-F238E27FC236}">
-                <a16:creationId xmlns:a16="http://schemas.microsoft.com/office/drawing/2014/main" id="{19FBDEF7-7C74-4A00-8B45-2A9B12FCB234}"/>
+                <a16:creationId xmlns:a16="http://schemas.microsoft.com/office/drawing/2014/main" id="{656A63EE-61FF-479D-A0D6-8B316BF397AB}"/>
               </a:ext>
             </a:extLst>
           </p:cNvPr>
@@ -1055,8 +1055,8 @@
         </p:nvSpPr>
         <p:spPr>
           <a:xfrm xmlns:a="http://schemas.openxmlformats.org/drawingml/2006/main">
-            <a:off x="3619500" y="1676400"/>
-            <a:ext cx="7391400" cy="304800"/>
+            <a:off x="3619500" y="1695450"/>
+            <a:ext cx="7391400" cy="285750"/>
           </a:xfrm>
           <a:prstGeom xmlns:a="http://schemas.openxmlformats.org/drawingml/2006/main" prst="rect">
             <a:avLst/>
@@ -1080,23 +1080,27 @@
           <a:lstStyle xmlns:a="http://schemas.openxmlformats.org/drawingml/2006/main"/>
           <a:p xmlns:a="http://schemas.openxmlformats.org/drawingml/2006/main">
             <a:pPr algn="ctr">
-              <a:defRPr sz="1350" b="0">
+              <a:defRPr sz="1200" b="0">
                 <a:solidFill>
-                  <a:srgbClr val="57748D"/>
+                  <a:srgbClr val="6B8396">
+                    <a:alpha val="60000"/>
+                  </a:srgbClr>
                 </a:solidFill>
-                <a:latin typeface="Microsoft JhengHei"/>
-                <a:ea typeface="Microsoft JhengHei"/>
-                <a:cs typeface="Microsoft JhengHei"/>
+                <a:latin typeface="Microsoft JhengHei Light"/>
+                <a:ea typeface="Microsoft JhengHei Light"/>
+                <a:cs typeface="Microsoft JhengHei Light"/>
               </a:defRPr>
             </a:pPr>
             <a:r>
-              <a:rPr sz="1350" b="0">
+              <a:rPr sz="1200" b="0">
                 <a:solidFill>
-                  <a:srgbClr val="57748D"/>
+                  <a:srgbClr val="6B8396">
+                    <a:alpha val="60000"/>
+                  </a:srgbClr>
                 </a:solidFill>
-                <a:latin typeface="Microsoft JhengHei"/>
-                <a:ea typeface="Microsoft JhengHei"/>
-                <a:cs typeface="Microsoft JhengHei"/>
+                <a:latin typeface="Microsoft JhengHei Light"/>
+                <a:ea typeface="Microsoft JhengHei Light"/>
+                <a:cs typeface="Microsoft JhengHei Light"/>
               </a:rPr>
               <a:t>讓租屋資訊，從廣告走向透明。</a:t>
             </a:r>
@@ -1105,10 +1109,10 @@
       </p:sp>
       <p:sp>
         <p:nvSpPr>
-          <p:cNvPr id="6" name="team-name-glow">
+          <p:cNvPr id="6" name="team-name-soft-fire-panel">
             <a:extLst xmlns:a="http://schemas.openxmlformats.org/drawingml/2006/main">
               <a:ext uri="{FF2B5EF4-FFF2-40B4-BE49-F238E27FC236}">
-                <a16:creationId xmlns:a16="http://schemas.microsoft.com/office/drawing/2014/main" id="{A17995D3-312C-464E-9C66-5FB699DAE66B}"/>
+                <a16:creationId xmlns:a16="http://schemas.microsoft.com/office/drawing/2014/main" id="{9F0BCD53-9A65-4C04-A89B-66DF34D44D08}"/>
               </a:ext>
             </a:extLst>
           </p:cNvPr>
@@ -1119,21 +1123,21 @@
         </p:nvSpPr>
         <p:spPr>
           <a:xfrm xmlns:a="http://schemas.openxmlformats.org/drawingml/2006/main">
-            <a:off x="4572000" y="7810500"/>
-            <a:ext cx="5486400" cy="514350"/>
+            <a:off x="4724400" y="7800975"/>
+            <a:ext cx="5181600" cy="495300"/>
           </a:xfrm>
           <a:prstGeom xmlns:a="http://schemas.openxmlformats.org/drawingml/2006/main" prst="rect">
             <a:avLst/>
           </a:prstGeom>
           <a:solidFill xmlns:a="http://schemas.openxmlformats.org/drawingml/2006/main">
-            <a:srgbClr val="FFF5D0">
-              <a:alpha val="50196"/>
+            <a:srgbClr val="FFF1BD">
+              <a:alpha val="21961"/>
             </a:srgbClr>
           </a:solidFill>
-          <a:ln xmlns:a="http://schemas.openxmlformats.org/drawingml/2006/main" w="9525">
+          <a:ln xmlns:a="http://schemas.openxmlformats.org/drawingml/2006/main" w="4763">
             <a:solidFill>
-              <a:srgbClr val="DDAA48">
-                <a:alpha val="40000"/>
+              <a:srgbClr val="F4C56A">
+                <a:alpha val="13333"/>
               </a:srgbClr>
             </a:solidFill>
             <a:prstDash val="solid"/>
@@ -1142,10 +1146,10 @@
       </p:sp>
       <p:sp>
         <p:nvSpPr>
-          <p:cNvPr id="7" name="team-name">
+          <p:cNvPr id="7" name="team-name-warm-glow">
             <a:extLst xmlns:a="http://schemas.openxmlformats.org/drawingml/2006/main">
               <a:ext uri="{FF2B5EF4-FFF2-40B4-BE49-F238E27FC236}">
-                <a16:creationId xmlns:a16="http://schemas.microsoft.com/office/drawing/2014/main" id="{56312622-4DEC-4A26-8628-3237600F00ED}"/>
+                <a16:creationId xmlns:a16="http://schemas.microsoft.com/office/drawing/2014/main" id="{87CB4EBC-0784-43B9-BE5E-1E52C5163AD3}"/>
               </a:ext>
             </a:extLst>
           </p:cNvPr>
@@ -1156,8 +1160,8 @@
         </p:nvSpPr>
         <p:spPr>
           <a:xfrm xmlns:a="http://schemas.openxmlformats.org/drawingml/2006/main">
-            <a:off x="4476750" y="7867650"/>
-            <a:ext cx="5676900" cy="400050"/>
+            <a:off x="4533900" y="7839075"/>
+            <a:ext cx="5562600" cy="419100"/>
           </a:xfrm>
           <a:prstGeom xmlns:a="http://schemas.openxmlformats.org/drawingml/2006/main" prst="rect">
             <a:avLst/>
@@ -1181,9 +1185,11 @@
           <a:lstStyle xmlns:a="http://schemas.openxmlformats.org/drawingml/2006/main"/>
           <a:p xmlns:a="http://schemas.openxmlformats.org/drawingml/2006/main">
             <a:pPr algn="ctr">
-              <a:defRPr sz="2100" b="0">
+              <a:defRPr sz="1875" b="0">
                 <a:solidFill>
-                  <a:srgbClr val="4A3A22"/>
+                  <a:srgbClr val="FFDFAE">
+                    <a:alpha val="53333"/>
+                  </a:srgbClr>
                 </a:solidFill>
                 <a:latin typeface="Microsoft JhengHei"/>
                 <a:ea typeface="Microsoft JhengHei"/>
@@ -1191,25 +1197,95 @@
               </a:defRPr>
             </a:pPr>
             <a:r>
-              <a:rPr sz="2100" b="0">
+              <a:rPr sz="1875" b="0">
                 <a:solidFill>
-                  <a:srgbClr val="4A3A22"/>
+                  <a:srgbClr val="FFDFAE">
+                    <a:alpha val="53333"/>
+                  </a:srgbClr>
                 </a:solidFill>
                 <a:latin typeface="Microsoft JhengHei"/>
                 <a:ea typeface="Microsoft JhengHei"/>
                 <a:cs typeface="Microsoft JhengHei"/>
               </a:rPr>
-              <a:t>不動業火笙聲生不熄</a:t>
+              <a:t>不 動 業 火 笙 聲 生 不 熄</a:t>
             </a:r>
           </a:p>
         </p:txBody>
       </p:sp>
       <p:sp>
         <p:nvSpPr>
-          <p:cNvPr id="8" name="members-panel">
+          <p:cNvPr id="8" name="team-name">
             <a:extLst xmlns:a="http://schemas.openxmlformats.org/drawingml/2006/main">
               <a:ext uri="{FF2B5EF4-FFF2-40B4-BE49-F238E27FC236}">
-                <a16:creationId xmlns:a16="http://schemas.microsoft.com/office/drawing/2014/main" id="{901328F8-BE92-4B3A-A2D3-DF1497ADEC62}"/>
+                <a16:creationId xmlns:a16="http://schemas.microsoft.com/office/drawing/2014/main" id="{F8783291-E803-476E-B72B-6B5C8DEE8579}"/>
+              </a:ext>
+            </a:extLst>
+          </p:cNvPr>
+          <p:cNvSpPr>
+            <a:spLocks xmlns:a="http://schemas.openxmlformats.org/drawingml/2006/main" noGrp="1"/>
+          </p:cNvSpPr>
+          <p:nvPr/>
+        </p:nvSpPr>
+        <p:spPr>
+          <a:xfrm xmlns:a="http://schemas.openxmlformats.org/drawingml/2006/main">
+            <a:off x="4533900" y="7867650"/>
+            <a:ext cx="5562600" cy="400050"/>
+          </a:xfrm>
+          <a:prstGeom xmlns:a="http://schemas.openxmlformats.org/drawingml/2006/main" prst="rect">
+            <a:avLst/>
+          </a:prstGeom>
+          <a:solidFill xmlns:a="http://schemas.openxmlformats.org/drawingml/2006/main">
+            <a:srgbClr val="000000">
+              <a:alpha val="0"/>
+            </a:srgbClr>
+          </a:solidFill>
+          <a:ln xmlns:a="http://schemas.openxmlformats.org/drawingml/2006/main" w="0">
+            <a:solidFill>
+              <a:srgbClr val="000000">
+                <a:alpha val="0"/>
+              </a:srgbClr>
+            </a:solidFill>
+            <a:prstDash val="solid"/>
+          </a:ln>
+        </p:spPr>
+        <p:txBody>
+          <a:bodyPr xmlns:a="http://schemas.openxmlformats.org/drawingml/2006/main" lIns="0" tIns="0" rIns="0" bIns="0" anchor="t"/>
+          <a:lstStyle xmlns:a="http://schemas.openxmlformats.org/drawingml/2006/main"/>
+          <a:p xmlns:a="http://schemas.openxmlformats.org/drawingml/2006/main">
+            <a:pPr algn="ctr">
+              <a:defRPr sz="1875" b="0">
+                <a:solidFill>
+                  <a:srgbClr val="4A3929">
+                    <a:alpha val="86667"/>
+                  </a:srgbClr>
+                </a:solidFill>
+                <a:latin typeface="Microsoft JhengHei"/>
+                <a:ea typeface="Microsoft JhengHei"/>
+                <a:cs typeface="Microsoft JhengHei"/>
+              </a:defRPr>
+            </a:pPr>
+            <a:r>
+              <a:rPr sz="1875" b="0">
+                <a:solidFill>
+                  <a:srgbClr val="4A3929">
+                    <a:alpha val="86667"/>
+                  </a:srgbClr>
+                </a:solidFill>
+                <a:latin typeface="Microsoft JhengHei"/>
+                <a:ea typeface="Microsoft JhengHei"/>
+                <a:cs typeface="Microsoft JhengHei"/>
+              </a:rPr>
+              <a:t>不 動 業 火 笙 聲 生 不 熄</a:t>
+            </a:r>
+          </a:p>
+        </p:txBody>
+      </p:sp>
+      <p:sp>
+        <p:nvSpPr>
+          <p:cNvPr id="9" name="members-panel">
+            <a:extLst xmlns:a="http://schemas.openxmlformats.org/drawingml/2006/main">
+              <a:ext uri="{FF2B5EF4-FFF2-40B4-BE49-F238E27FC236}">
+                <a16:creationId xmlns:a16="http://schemas.microsoft.com/office/drawing/2014/main" id="{71283D21-FC93-4270-9E3B-007F28593560}"/>
               </a:ext>
             </a:extLst>
           </p:cNvPr>
@@ -1228,13 +1304,13 @@
           </a:prstGeom>
           <a:solidFill xmlns:a="http://schemas.openxmlformats.org/drawingml/2006/main">
             <a:srgbClr val="F7FBFF">
-              <a:alpha val="72157"/>
+              <a:alpha val="69020"/>
             </a:srgbClr>
           </a:solidFill>
-          <a:ln xmlns:a="http://schemas.openxmlformats.org/drawingml/2006/main" w="9525">
+          <a:ln xmlns:a="http://schemas.openxmlformats.org/drawingml/2006/main" w="7620">
             <a:solidFill>
               <a:srgbClr val="8AB8E6">
-                <a:alpha val="33333"/>
+                <a:alpha val="26667"/>
               </a:srgbClr>
             </a:solidFill>
             <a:prstDash val="solid"/>
@@ -1243,10 +1319,10 @@
       </p:sp>
       <p:sp>
         <p:nvSpPr>
-          <p:cNvPr id="9" name="members-label">
+          <p:cNvPr id="10" name="members-label">
             <a:extLst xmlns:a="http://schemas.openxmlformats.org/drawingml/2006/main">
               <a:ext uri="{FF2B5EF4-FFF2-40B4-BE49-F238E27FC236}">
-                <a16:creationId xmlns:a16="http://schemas.microsoft.com/office/drawing/2014/main" id="{30030295-CF37-4822-9427-1C89FB292408}"/>
+                <a16:creationId xmlns:a16="http://schemas.microsoft.com/office/drawing/2014/main" id="{C27C997B-6550-4DE3-9443-7F9803805155}"/>
               </a:ext>
             </a:extLst>
           </p:cNvPr>
@@ -1307,10 +1383,10 @@
       </p:sp>
       <p:sp>
         <p:nvSpPr>
-          <p:cNvPr id="10" name="members-names">
+          <p:cNvPr id="11" name="members-names">
             <a:extLst xmlns:a="http://schemas.openxmlformats.org/drawingml/2006/main">
               <a:ext uri="{FF2B5EF4-FFF2-40B4-BE49-F238E27FC236}">
-                <a16:creationId xmlns:a16="http://schemas.microsoft.com/office/drawing/2014/main" id="{F001B935-80D3-443B-95F2-D08B9E9A5812}"/>
+                <a16:creationId xmlns:a16="http://schemas.microsoft.com/office/drawing/2014/main" id="{05A9CB7A-4389-4534-A6FA-783AFAB5F6B6}"/>
               </a:ext>
             </a:extLst>
           </p:cNvPr>
@@ -1372,7 +1448,7 @@
     </p:spTree>
     <p:extLst>
       <p:ext uri="{BB962C8B-B14F-4D97-AF65-F5344CB8AC3E}">
-        <p14:creationId xmlns:p14="http://schemas.microsoft.com/office/powerpoint/2010/main" val="1135855289"/>
+        <p14:creationId xmlns:p14="http://schemas.microsoft.com/office/powerpoint/2010/main" val="1430502626"/>
       </p:ext>
     </p:extLst>
   </p:cSld>

</xml_diff>

<commit_message>
Emphasize proposal cover title
</commit_message>
<xml_diff>
--- a/Rent-Unfiltered-計畫書封面.pptx
+++ b/Rent-Unfiltered-計畫書封面.pptx
@@ -2,13 +2,13 @@
 <file path=ppt/presentation.xml><?xml version="1.0" encoding="utf-8"?>
 <p:presentation xmlns:p="http://schemas.openxmlformats.org/presentationml/2006/main">
   <p:sldMasterIdLst>
-    <p:sldMasterId xmlns:r="http://schemas.openxmlformats.org/officeDocument/2006/relationships" id="2147483648" r:id="Rc6dfb243ad264006"/>
+    <p:sldMasterId xmlns:r="http://schemas.openxmlformats.org/officeDocument/2006/relationships" id="2147483648" r:id="Rf05bad3abcd44867"/>
   </p:sldMasterIdLst>
   <p:notesMasterIdLst>
-    <p:notesMasterId xmlns:r="http://schemas.openxmlformats.org/officeDocument/2006/relationships" r:id="Rd9d1a094ad9d483b"/>
+    <p:notesMasterId xmlns:r="http://schemas.openxmlformats.org/officeDocument/2006/relationships" r:id="Rcba332e56de344c7"/>
   </p:notesMasterIdLst>
   <p:sldIdLst>
-    <p:sldId xmlns:r="http://schemas.openxmlformats.org/officeDocument/2006/relationships" id="256" r:id="R639c28180ace4504"/>
+    <p:sldId xmlns:r="http://schemas.openxmlformats.org/officeDocument/2006/relationships" id="256" r:id="R326a53f51a714534"/>
   </p:sldIdLst>
   <p:sldSz cx="14630400" cy="9753600"/>
   <p:notesSz cx="6858000" cy="9144000"/>
@@ -555,7 +555,7 @@
   </p:cSld>
   <p:clrMap bg1="lt1" tx1="dk1" bg2="lt2" tx2="dk2" accent1="accent1" accent2="accent2" accent3="accent3" accent4="accent4" accent5="accent5" accent6="accent6" hlink="hlink" folHlink="folHlink"/>
   <p:sldLayoutIdLst>
-    <p:sldLayoutId xmlns:r="http://schemas.openxmlformats.org/officeDocument/2006/relationships" id="2147483649" r:id="Raf732d1ac35b48c5"/>
+    <p:sldLayoutId xmlns:r="http://schemas.openxmlformats.org/officeDocument/2006/relationships" id="2147483649" r:id="Rbdc78739805443c8"/>
   </p:sldLayoutIdLst>
   <p:txStyles>
     <p:titleStyle>
@@ -858,7 +858,7 @@
           <p:nvPr/>
         </p:nvPicPr>
         <p:blipFill>
-          <a:blip xmlns:r="http://schemas.openxmlformats.org/officeDocument/2006/relationships" xmlns:a="http://schemas.openxmlformats.org/drawingml/2006/main" r:embed="Raa1de0ba6d6a4137"/>
+          <a:blip xmlns:r="http://schemas.openxmlformats.org/officeDocument/2006/relationships" xmlns:a="http://schemas.openxmlformats.org/drawingml/2006/main" r:embed="R0a84d4931c9948d8"/>
           <a:srcRect xmlns:a="http://schemas.openxmlformats.org/drawingml/2006/main" l="0" t="0" r="0" b="0"/>
           <a:stretch xmlns:a="http://schemas.openxmlformats.org/drawingml/2006/main">
             <a:fillRect l="0" t="0" r="0" b="0"/>
@@ -879,7 +879,7 @@
           <p:cNvPr id="2" name="title-soft-panel">
             <a:extLst xmlns:a="http://schemas.openxmlformats.org/drawingml/2006/main">
               <a:ext uri="{FF2B5EF4-FFF2-40B4-BE49-F238E27FC236}">
-                <a16:creationId xmlns:a16="http://schemas.microsoft.com/office/drawing/2014/main" id="{EB42465A-F0BF-4D8B-BE6E-9669911D0FCC}"/>
+                <a16:creationId xmlns:a16="http://schemas.microsoft.com/office/drawing/2014/main" id="{C0C5C7DA-32AE-4EC2-989F-AF858EF5903E}"/>
               </a:ext>
             </a:extLst>
           </p:cNvPr>
@@ -916,7 +916,7 @@
           <p:cNvPr id="3" name="project-title-en">
             <a:extLst xmlns:a="http://schemas.openxmlformats.org/drawingml/2006/main">
               <a:ext uri="{FF2B5EF4-FFF2-40B4-BE49-F238E27FC236}">
-                <a16:creationId xmlns:a16="http://schemas.microsoft.com/office/drawing/2014/main" id="{79214D05-2D40-495A-8053-32CB60DC21F7}"/>
+                <a16:creationId xmlns:a16="http://schemas.microsoft.com/office/drawing/2014/main" id="{64533394-52BB-4924-A20C-2EAF5BF911EB}"/>
               </a:ext>
             </a:extLst>
           </p:cNvPr>
@@ -927,8 +927,8 @@
         </p:nvSpPr>
         <p:spPr>
           <a:xfrm xmlns:a="http://schemas.openxmlformats.org/drawingml/2006/main">
-            <a:off x="3333750" y="552450"/>
-            <a:ext cx="7962900" cy="514350"/>
+            <a:off x="3333750" y="533400"/>
+            <a:ext cx="7962900" cy="533400"/>
           </a:xfrm>
           <a:prstGeom xmlns:a="http://schemas.openxmlformats.org/drawingml/2006/main" prst="rect">
             <a:avLst/>
@@ -952,9 +952,9 @@
           <a:lstStyle xmlns:a="http://schemas.openxmlformats.org/drawingml/2006/main"/>
           <a:p xmlns:a="http://schemas.openxmlformats.org/drawingml/2006/main">
             <a:pPr algn="ctr">
-              <a:defRPr sz="2775" b="0">
+              <a:defRPr sz="2925" b="1">
                 <a:solidFill>
-                  <a:srgbClr val="244A70"/>
+                  <a:srgbClr val="153A5F"/>
                 </a:solidFill>
                 <a:latin typeface="Aptos Display"/>
                 <a:ea typeface="Aptos Display"/>
@@ -962,9 +962,9 @@
               </a:defRPr>
             </a:pPr>
             <a:r>
-              <a:rPr sz="2775" b="0">
+              <a:rPr sz="2925" b="1">
                 <a:solidFill>
-                  <a:srgbClr val="244A70"/>
+                  <a:srgbClr val="153A5F"/>
                 </a:solidFill>
                 <a:latin typeface="Aptos Display"/>
                 <a:ea typeface="Aptos Display"/>
@@ -980,7 +980,7 @@
           <p:cNvPr id="4" name="project-title-zh">
             <a:extLst xmlns:a="http://schemas.openxmlformats.org/drawingml/2006/main">
               <a:ext uri="{FF2B5EF4-FFF2-40B4-BE49-F238E27FC236}">
-                <a16:creationId xmlns:a16="http://schemas.microsoft.com/office/drawing/2014/main" id="{7E0DBF4D-E4CD-4C13-BE59-590BC0222F3C}"/>
+                <a16:creationId xmlns:a16="http://schemas.microsoft.com/office/drawing/2014/main" id="{B42A6154-78DC-42FC-B9B7-EB17BDEAA57C}"/>
               </a:ext>
             </a:extLst>
           </p:cNvPr>
@@ -991,8 +991,8 @@
         </p:nvSpPr>
         <p:spPr>
           <a:xfrm xmlns:a="http://schemas.openxmlformats.org/drawingml/2006/main">
-            <a:off x="3333750" y="1047750"/>
-            <a:ext cx="7962900" cy="628650"/>
+            <a:off x="3333750" y="1028700"/>
+            <a:ext cx="7962900" cy="647700"/>
           </a:xfrm>
           <a:prstGeom xmlns:a="http://schemas.openxmlformats.org/drawingml/2006/main" prst="rect">
             <a:avLst/>
@@ -1016,23 +1016,23 @@
           <a:lstStyle xmlns:a="http://schemas.openxmlformats.org/drawingml/2006/main"/>
           <a:p xmlns:a="http://schemas.openxmlformats.org/drawingml/2006/main">
             <a:pPr algn="ctr">
-              <a:defRPr sz="3450" b="0">
+              <a:defRPr sz="3675" b="1">
                 <a:solidFill>
-                  <a:srgbClr val="163755"/>
+                  <a:srgbClr val="0D2F4E"/>
                 </a:solidFill>
-                <a:latin typeface="Microsoft JhengHei Light"/>
-                <a:ea typeface="Microsoft JhengHei Light"/>
-                <a:cs typeface="Microsoft JhengHei Light"/>
+                <a:latin typeface="Microsoft JhengHei"/>
+                <a:ea typeface="Microsoft JhengHei"/>
+                <a:cs typeface="Microsoft JhengHei"/>
               </a:defRPr>
             </a:pPr>
             <a:r>
-              <a:rPr sz="3450" b="0">
+              <a:rPr sz="3675" b="1">
                 <a:solidFill>
-                  <a:srgbClr val="163755"/>
+                  <a:srgbClr val="0D2F4E"/>
                 </a:solidFill>
-                <a:latin typeface="Microsoft JhengHei Light"/>
-                <a:ea typeface="Microsoft JhengHei Light"/>
-                <a:cs typeface="Microsoft JhengHei Light"/>
+                <a:latin typeface="Microsoft JhengHei"/>
+                <a:ea typeface="Microsoft JhengHei"/>
+                <a:cs typeface="Microsoft JhengHei"/>
               </a:rPr>
               <a:t>透明租屋</a:t>
             </a:r>
@@ -1044,7 +1044,7 @@
           <p:cNvPr id="5" name="cover-slogan">
             <a:extLst xmlns:a="http://schemas.openxmlformats.org/drawingml/2006/main">
               <a:ext uri="{FF2B5EF4-FFF2-40B4-BE49-F238E27FC236}">
-                <a16:creationId xmlns:a16="http://schemas.microsoft.com/office/drawing/2014/main" id="{656A63EE-61FF-479D-A0D6-8B316BF397AB}"/>
+                <a16:creationId xmlns:a16="http://schemas.microsoft.com/office/drawing/2014/main" id="{EE14A0CB-9D3E-400F-AEE4-52283AA6DD2F}"/>
               </a:ext>
             </a:extLst>
           </p:cNvPr>
@@ -1082,7 +1082,7 @@
             <a:pPr algn="ctr">
               <a:defRPr sz="1200" b="0">
                 <a:solidFill>
-                  <a:srgbClr val="6B8396">
+                  <a:srgbClr val="617B90">
                     <a:alpha val="60000"/>
                   </a:srgbClr>
                 </a:solidFill>
@@ -1094,7 +1094,7 @@
             <a:r>
               <a:rPr sz="1200" b="0">
                 <a:solidFill>
-                  <a:srgbClr val="6B8396">
+                  <a:srgbClr val="617B90">
                     <a:alpha val="60000"/>
                   </a:srgbClr>
                 </a:solidFill>
@@ -1112,7 +1112,7 @@
           <p:cNvPr id="6" name="team-name-soft-fire-panel">
             <a:extLst xmlns:a="http://schemas.openxmlformats.org/drawingml/2006/main">
               <a:ext uri="{FF2B5EF4-FFF2-40B4-BE49-F238E27FC236}">
-                <a16:creationId xmlns:a16="http://schemas.microsoft.com/office/drawing/2014/main" id="{9F0BCD53-9A65-4C04-A89B-66DF34D44D08}"/>
+                <a16:creationId xmlns:a16="http://schemas.microsoft.com/office/drawing/2014/main" id="{00D8AD49-A263-495F-B443-E5A5E854BFC8}"/>
               </a:ext>
             </a:extLst>
           </p:cNvPr>
@@ -1149,7 +1149,7 @@
           <p:cNvPr id="7" name="team-name-warm-glow">
             <a:extLst xmlns:a="http://schemas.openxmlformats.org/drawingml/2006/main">
               <a:ext uri="{FF2B5EF4-FFF2-40B4-BE49-F238E27FC236}">
-                <a16:creationId xmlns:a16="http://schemas.microsoft.com/office/drawing/2014/main" id="{87CB4EBC-0784-43B9-BE5E-1E52C5163AD3}"/>
+                <a16:creationId xmlns:a16="http://schemas.microsoft.com/office/drawing/2014/main" id="{8DC19086-32F7-4297-B890-DC5B6C7CD480}"/>
               </a:ext>
             </a:extLst>
           </p:cNvPr>
@@ -1217,7 +1217,7 @@
           <p:cNvPr id="8" name="team-name">
             <a:extLst xmlns:a="http://schemas.openxmlformats.org/drawingml/2006/main">
               <a:ext uri="{FF2B5EF4-FFF2-40B4-BE49-F238E27FC236}">
-                <a16:creationId xmlns:a16="http://schemas.microsoft.com/office/drawing/2014/main" id="{F8783291-E803-476E-B72B-6B5C8DEE8579}"/>
+                <a16:creationId xmlns:a16="http://schemas.microsoft.com/office/drawing/2014/main" id="{E27F245B-892A-4220-B2C5-18AB3C354473}"/>
               </a:ext>
             </a:extLst>
           </p:cNvPr>
@@ -1285,7 +1285,7 @@
           <p:cNvPr id="9" name="members-panel">
             <a:extLst xmlns:a="http://schemas.openxmlformats.org/drawingml/2006/main">
               <a:ext uri="{FF2B5EF4-FFF2-40B4-BE49-F238E27FC236}">
-                <a16:creationId xmlns:a16="http://schemas.microsoft.com/office/drawing/2014/main" id="{71283D21-FC93-4270-9E3B-007F28593560}"/>
+                <a16:creationId xmlns:a16="http://schemas.microsoft.com/office/drawing/2014/main" id="{CEC99ECB-FE0D-431C-9B54-38566C1A7C47}"/>
               </a:ext>
             </a:extLst>
           </p:cNvPr>
@@ -1322,7 +1322,7 @@
           <p:cNvPr id="10" name="members-label">
             <a:extLst xmlns:a="http://schemas.openxmlformats.org/drawingml/2006/main">
               <a:ext uri="{FF2B5EF4-FFF2-40B4-BE49-F238E27FC236}">
-                <a16:creationId xmlns:a16="http://schemas.microsoft.com/office/drawing/2014/main" id="{C27C997B-6550-4DE3-9443-7F9803805155}"/>
+                <a16:creationId xmlns:a16="http://schemas.microsoft.com/office/drawing/2014/main" id="{951A52CC-0430-45D0-B303-54C0B143FF2F}"/>
               </a:ext>
             </a:extLst>
           </p:cNvPr>
@@ -1386,7 +1386,7 @@
           <p:cNvPr id="11" name="members-names">
             <a:extLst xmlns:a="http://schemas.openxmlformats.org/drawingml/2006/main">
               <a:ext uri="{FF2B5EF4-FFF2-40B4-BE49-F238E27FC236}">
-                <a16:creationId xmlns:a16="http://schemas.microsoft.com/office/drawing/2014/main" id="{05A9CB7A-4389-4534-A6FA-783AFAB5F6B6}"/>
+                <a16:creationId xmlns:a16="http://schemas.microsoft.com/office/drawing/2014/main" id="{66375759-1AC0-4EC5-9757-608B9C21BBC4}"/>
               </a:ext>
             </a:extLst>
           </p:cNvPr>
@@ -1448,7 +1448,7 @@
     </p:spTree>
     <p:extLst>
       <p:ext uri="{BB962C8B-B14F-4D97-AF65-F5344CB8AC3E}">
-        <p14:creationId xmlns:p14="http://schemas.microsoft.com/office/powerpoint/2010/main" val="1430502626"/>
+        <p14:creationId xmlns:p14="http://schemas.microsoft.com/office/powerpoint/2010/main" val="1598537934"/>
       </p:ext>
     </p:extLst>
   </p:cSld>

</xml_diff>

<commit_message>
Center proposal title on cover screen
</commit_message>
<xml_diff>
--- a/Rent-Unfiltered-計畫書封面.pptx
+++ b/Rent-Unfiltered-計畫書封面.pptx
@@ -2,13 +2,13 @@
 <file path=ppt/presentation.xml><?xml version="1.0" encoding="utf-8"?>
 <p:presentation xmlns:p="http://schemas.openxmlformats.org/presentationml/2006/main">
   <p:sldMasterIdLst>
-    <p:sldMasterId xmlns:r="http://schemas.openxmlformats.org/officeDocument/2006/relationships" id="2147483648" r:id="Rf05bad3abcd44867"/>
+    <p:sldMasterId xmlns:r="http://schemas.openxmlformats.org/officeDocument/2006/relationships" id="2147483648" r:id="R39e5c3ffab2145c7"/>
   </p:sldMasterIdLst>
   <p:notesMasterIdLst>
-    <p:notesMasterId xmlns:r="http://schemas.openxmlformats.org/officeDocument/2006/relationships" r:id="Rcba332e56de344c7"/>
+    <p:notesMasterId xmlns:r="http://schemas.openxmlformats.org/officeDocument/2006/relationships" r:id="Rac447c014a3f4a60"/>
   </p:notesMasterIdLst>
   <p:sldIdLst>
-    <p:sldId xmlns:r="http://schemas.openxmlformats.org/officeDocument/2006/relationships" id="256" r:id="R326a53f51a714534"/>
+    <p:sldId xmlns:r="http://schemas.openxmlformats.org/officeDocument/2006/relationships" id="256" r:id="R0e9c96114634488d"/>
   </p:sldIdLst>
   <p:sldSz cx="14630400" cy="9753600"/>
   <p:notesSz cx="6858000" cy="9144000"/>
@@ -555,7 +555,7 @@
   </p:cSld>
   <p:clrMap bg1="lt1" tx1="dk1" bg2="lt2" tx2="dk2" accent1="accent1" accent2="accent2" accent3="accent3" accent4="accent4" accent5="accent5" accent6="accent6" hlink="hlink" folHlink="folHlink"/>
   <p:sldLayoutIdLst>
-    <p:sldLayoutId xmlns:r="http://schemas.openxmlformats.org/officeDocument/2006/relationships" id="2147483649" r:id="Rbdc78739805443c8"/>
+    <p:sldLayoutId xmlns:r="http://schemas.openxmlformats.org/officeDocument/2006/relationships" id="2147483649" r:id="R8994ef64a2034a6f"/>
   </p:sldLayoutIdLst>
   <p:txStyles>
     <p:titleStyle>
@@ -858,7 +858,7 @@
           <p:nvPr/>
         </p:nvPicPr>
         <p:blipFill>
-          <a:blip xmlns:r="http://schemas.openxmlformats.org/officeDocument/2006/relationships" xmlns:a="http://schemas.openxmlformats.org/drawingml/2006/main" r:embed="R0a84d4931c9948d8"/>
+          <a:blip xmlns:r="http://schemas.openxmlformats.org/officeDocument/2006/relationships" xmlns:a="http://schemas.openxmlformats.org/drawingml/2006/main" r:embed="R41e2792c2e094d48"/>
           <a:srcRect xmlns:a="http://schemas.openxmlformats.org/drawingml/2006/main" l="0" t="0" r="0" b="0"/>
           <a:stretch xmlns:a="http://schemas.openxmlformats.org/drawingml/2006/main">
             <a:fillRect l="0" t="0" r="0" b="0"/>
@@ -876,10 +876,10 @@
       </p:pic>
       <p:sp>
         <p:nvSpPr>
-          <p:cNvPr id="2" name="title-soft-panel">
+          <p:cNvPr id="2" name="title-projection-panel">
             <a:extLst xmlns:a="http://schemas.openxmlformats.org/drawingml/2006/main">
               <a:ext uri="{FF2B5EF4-FFF2-40B4-BE49-F238E27FC236}">
-                <a16:creationId xmlns:a16="http://schemas.microsoft.com/office/drawing/2014/main" id="{C0C5C7DA-32AE-4EC2-989F-AF858EF5903E}"/>
+                <a16:creationId xmlns:a16="http://schemas.microsoft.com/office/drawing/2014/main" id="{F5549E91-4C5D-465E-AE72-35CEA4721282}"/>
               </a:ext>
             </a:extLst>
           </p:cNvPr>
@@ -890,21 +890,21 @@
         </p:nvSpPr>
         <p:spPr>
           <a:xfrm xmlns:a="http://schemas.openxmlformats.org/drawingml/2006/main">
-            <a:off x="3086100" y="323850"/>
-            <a:ext cx="8458200" cy="1714500"/>
+            <a:off x="2628900" y="781050"/>
+            <a:ext cx="9372600" cy="2209800"/>
           </a:xfrm>
           <a:prstGeom xmlns:a="http://schemas.openxmlformats.org/drawingml/2006/main" prst="rect">
             <a:avLst/>
           </a:prstGeom>
           <a:solidFill xmlns:a="http://schemas.openxmlformats.org/drawingml/2006/main">
             <a:srgbClr val="F8FBFF">
-              <a:alpha val="33333"/>
+              <a:alpha val="25882"/>
             </a:srgbClr>
           </a:solidFill>
           <a:ln xmlns:a="http://schemas.openxmlformats.org/drawingml/2006/main" w="4763">
             <a:solidFill>
               <a:srgbClr val="C7DDF0">
-                <a:alpha val="20000"/>
+                <a:alpha val="14902"/>
               </a:srgbClr>
             </a:solidFill>
             <a:prstDash val="solid"/>
@@ -916,7 +916,7 @@
           <p:cNvPr id="3" name="project-title-en">
             <a:extLst xmlns:a="http://schemas.openxmlformats.org/drawingml/2006/main">
               <a:ext uri="{FF2B5EF4-FFF2-40B4-BE49-F238E27FC236}">
-                <a16:creationId xmlns:a16="http://schemas.microsoft.com/office/drawing/2014/main" id="{64533394-52BB-4924-A20C-2EAF5BF911EB}"/>
+                <a16:creationId xmlns:a16="http://schemas.microsoft.com/office/drawing/2014/main" id="{BE7E9BB2-4709-4F22-816C-783AA4767C36}"/>
               </a:ext>
             </a:extLst>
           </p:cNvPr>
@@ -927,8 +927,8 @@
         </p:nvSpPr>
         <p:spPr>
           <a:xfrm xmlns:a="http://schemas.openxmlformats.org/drawingml/2006/main">
-            <a:off x="3333750" y="533400"/>
-            <a:ext cx="7962900" cy="533400"/>
+            <a:off x="2914650" y="1066800"/>
+            <a:ext cx="8801100" cy="628650"/>
           </a:xfrm>
           <a:prstGeom xmlns:a="http://schemas.openxmlformats.org/drawingml/2006/main" prst="rect">
             <a:avLst/>
@@ -952,9 +952,9 @@
           <a:lstStyle xmlns:a="http://schemas.openxmlformats.org/drawingml/2006/main"/>
           <a:p xmlns:a="http://schemas.openxmlformats.org/drawingml/2006/main">
             <a:pPr algn="ctr">
-              <a:defRPr sz="2925" b="1">
+              <a:defRPr sz="3450" b="1">
                 <a:solidFill>
-                  <a:srgbClr val="153A5F"/>
+                  <a:srgbClr val="123557"/>
                 </a:solidFill>
                 <a:latin typeface="Aptos Display"/>
                 <a:ea typeface="Aptos Display"/>
@@ -962,9 +962,9 @@
               </a:defRPr>
             </a:pPr>
             <a:r>
-              <a:rPr sz="2925" b="1">
+              <a:rPr sz="3450" b="1">
                 <a:solidFill>
-                  <a:srgbClr val="153A5F"/>
+                  <a:srgbClr val="123557"/>
                 </a:solidFill>
                 <a:latin typeface="Aptos Display"/>
                 <a:ea typeface="Aptos Display"/>
@@ -980,7 +980,7 @@
           <p:cNvPr id="4" name="project-title-zh">
             <a:extLst xmlns:a="http://schemas.openxmlformats.org/drawingml/2006/main">
               <a:ext uri="{FF2B5EF4-FFF2-40B4-BE49-F238E27FC236}">
-                <a16:creationId xmlns:a16="http://schemas.microsoft.com/office/drawing/2014/main" id="{B42A6154-78DC-42FC-B9B7-EB17BDEAA57C}"/>
+                <a16:creationId xmlns:a16="http://schemas.microsoft.com/office/drawing/2014/main" id="{7FE305AA-79BA-49A3-B3F4-3DA622B6F5F4}"/>
               </a:ext>
             </a:extLst>
           </p:cNvPr>
@@ -991,8 +991,8 @@
         </p:nvSpPr>
         <p:spPr>
           <a:xfrm xmlns:a="http://schemas.openxmlformats.org/drawingml/2006/main">
-            <a:off x="3333750" y="1028700"/>
-            <a:ext cx="7962900" cy="647700"/>
+            <a:off x="2914650" y="1638300"/>
+            <a:ext cx="8801100" cy="819150"/>
           </a:xfrm>
           <a:prstGeom xmlns:a="http://schemas.openxmlformats.org/drawingml/2006/main" prst="rect">
             <a:avLst/>
@@ -1016,9 +1016,9 @@
           <a:lstStyle xmlns:a="http://schemas.openxmlformats.org/drawingml/2006/main"/>
           <a:p xmlns:a="http://schemas.openxmlformats.org/drawingml/2006/main">
             <a:pPr algn="ctr">
-              <a:defRPr sz="3675" b="1">
+              <a:defRPr sz="4650" b="1">
                 <a:solidFill>
-                  <a:srgbClr val="0D2F4E"/>
+                  <a:srgbClr val="082A47"/>
                 </a:solidFill>
                 <a:latin typeface="Microsoft JhengHei"/>
                 <a:ea typeface="Microsoft JhengHei"/>
@@ -1026,9 +1026,9 @@
               </a:defRPr>
             </a:pPr>
             <a:r>
-              <a:rPr sz="3675" b="1">
+              <a:rPr sz="4650" b="1">
                 <a:solidFill>
-                  <a:srgbClr val="0D2F4E"/>
+                  <a:srgbClr val="082A47"/>
                 </a:solidFill>
                 <a:latin typeface="Microsoft JhengHei"/>
                 <a:ea typeface="Microsoft JhengHei"/>
@@ -1044,7 +1044,7 @@
           <p:cNvPr id="5" name="cover-slogan">
             <a:extLst xmlns:a="http://schemas.openxmlformats.org/drawingml/2006/main">
               <a:ext uri="{FF2B5EF4-FFF2-40B4-BE49-F238E27FC236}">
-                <a16:creationId xmlns:a16="http://schemas.microsoft.com/office/drawing/2014/main" id="{EE14A0CB-9D3E-400F-AEE4-52283AA6DD2F}"/>
+                <a16:creationId xmlns:a16="http://schemas.microsoft.com/office/drawing/2014/main" id="{089D6A54-F363-4E62-9711-4891CA5BCF2C}"/>
               </a:ext>
             </a:extLst>
           </p:cNvPr>
@@ -1055,8 +1055,8 @@
         </p:nvSpPr>
         <p:spPr>
           <a:xfrm xmlns:a="http://schemas.openxmlformats.org/drawingml/2006/main">
-            <a:off x="3619500" y="1695450"/>
-            <a:ext cx="7391400" cy="285750"/>
+            <a:off x="3105150" y="2457450"/>
+            <a:ext cx="8420100" cy="342900"/>
           </a:xfrm>
           <a:prstGeom xmlns:a="http://schemas.openxmlformats.org/drawingml/2006/main" prst="rect">
             <a:avLst/>
@@ -1080,27 +1080,27 @@
           <a:lstStyle xmlns:a="http://schemas.openxmlformats.org/drawingml/2006/main"/>
           <a:p xmlns:a="http://schemas.openxmlformats.org/drawingml/2006/main">
             <a:pPr algn="ctr">
-              <a:defRPr sz="1200" b="0">
+              <a:defRPr sz="1575" b="0">
                 <a:solidFill>
-                  <a:srgbClr val="617B90">
-                    <a:alpha val="60000"/>
+                  <a:srgbClr val="395D78">
+                    <a:alpha val="80000"/>
                   </a:srgbClr>
                 </a:solidFill>
-                <a:latin typeface="Microsoft JhengHei Light"/>
-                <a:ea typeface="Microsoft JhengHei Light"/>
-                <a:cs typeface="Microsoft JhengHei Light"/>
+                <a:latin typeface="Microsoft JhengHei"/>
+                <a:ea typeface="Microsoft JhengHei"/>
+                <a:cs typeface="Microsoft JhengHei"/>
               </a:defRPr>
             </a:pPr>
             <a:r>
-              <a:rPr sz="1200" b="0">
+              <a:rPr sz="1575" b="0">
                 <a:solidFill>
-                  <a:srgbClr val="617B90">
-                    <a:alpha val="60000"/>
+                  <a:srgbClr val="395D78">
+                    <a:alpha val="80000"/>
                   </a:srgbClr>
                 </a:solidFill>
-                <a:latin typeface="Microsoft JhengHei Light"/>
-                <a:ea typeface="Microsoft JhengHei Light"/>
-                <a:cs typeface="Microsoft JhengHei Light"/>
+                <a:latin typeface="Microsoft JhengHei"/>
+                <a:ea typeface="Microsoft JhengHei"/>
+                <a:cs typeface="Microsoft JhengHei"/>
               </a:rPr>
               <a:t>讓租屋資訊，從廣告走向透明。</a:t>
             </a:r>
@@ -1112,7 +1112,7 @@
           <p:cNvPr id="6" name="team-name-soft-fire-panel">
             <a:extLst xmlns:a="http://schemas.openxmlformats.org/drawingml/2006/main">
               <a:ext uri="{FF2B5EF4-FFF2-40B4-BE49-F238E27FC236}">
-                <a16:creationId xmlns:a16="http://schemas.microsoft.com/office/drawing/2014/main" id="{00D8AD49-A263-495F-B443-E5A5E854BFC8}"/>
+                <a16:creationId xmlns:a16="http://schemas.microsoft.com/office/drawing/2014/main" id="{D2AA6EA4-7923-4C7F-988F-4EE088213A41}"/>
               </a:ext>
             </a:extLst>
           </p:cNvPr>
@@ -1149,7 +1149,7 @@
           <p:cNvPr id="7" name="team-name-warm-glow">
             <a:extLst xmlns:a="http://schemas.openxmlformats.org/drawingml/2006/main">
               <a:ext uri="{FF2B5EF4-FFF2-40B4-BE49-F238E27FC236}">
-                <a16:creationId xmlns:a16="http://schemas.microsoft.com/office/drawing/2014/main" id="{8DC19086-32F7-4297-B890-DC5B6C7CD480}"/>
+                <a16:creationId xmlns:a16="http://schemas.microsoft.com/office/drawing/2014/main" id="{86C6FD4F-AF6F-4460-B997-0851B0E91F1F}"/>
               </a:ext>
             </a:extLst>
           </p:cNvPr>
@@ -1217,7 +1217,7 @@
           <p:cNvPr id="8" name="team-name">
             <a:extLst xmlns:a="http://schemas.openxmlformats.org/drawingml/2006/main">
               <a:ext uri="{FF2B5EF4-FFF2-40B4-BE49-F238E27FC236}">
-                <a16:creationId xmlns:a16="http://schemas.microsoft.com/office/drawing/2014/main" id="{E27F245B-892A-4220-B2C5-18AB3C354473}"/>
+                <a16:creationId xmlns:a16="http://schemas.microsoft.com/office/drawing/2014/main" id="{E0FF8A42-AC26-4402-803E-FB5F7374BFF7}"/>
               </a:ext>
             </a:extLst>
           </p:cNvPr>
@@ -1285,7 +1285,7 @@
           <p:cNvPr id="9" name="members-panel">
             <a:extLst xmlns:a="http://schemas.openxmlformats.org/drawingml/2006/main">
               <a:ext uri="{FF2B5EF4-FFF2-40B4-BE49-F238E27FC236}">
-                <a16:creationId xmlns:a16="http://schemas.microsoft.com/office/drawing/2014/main" id="{CEC99ECB-FE0D-431C-9B54-38566C1A7C47}"/>
+                <a16:creationId xmlns:a16="http://schemas.microsoft.com/office/drawing/2014/main" id="{AA76E0A7-02AB-48C5-9AA2-BCB58A49F0DF}"/>
               </a:ext>
             </a:extLst>
           </p:cNvPr>
@@ -1322,7 +1322,7 @@
           <p:cNvPr id="10" name="members-label">
             <a:extLst xmlns:a="http://schemas.openxmlformats.org/drawingml/2006/main">
               <a:ext uri="{FF2B5EF4-FFF2-40B4-BE49-F238E27FC236}">
-                <a16:creationId xmlns:a16="http://schemas.microsoft.com/office/drawing/2014/main" id="{951A52CC-0430-45D0-B303-54C0B143FF2F}"/>
+                <a16:creationId xmlns:a16="http://schemas.microsoft.com/office/drawing/2014/main" id="{3AC06B04-393E-428B-92C7-C4D5507A4EDE}"/>
               </a:ext>
             </a:extLst>
           </p:cNvPr>
@@ -1386,7 +1386,7 @@
           <p:cNvPr id="11" name="members-names">
             <a:extLst xmlns:a="http://schemas.openxmlformats.org/drawingml/2006/main">
               <a:ext uri="{FF2B5EF4-FFF2-40B4-BE49-F238E27FC236}">
-                <a16:creationId xmlns:a16="http://schemas.microsoft.com/office/drawing/2014/main" id="{66375759-1AC0-4EC5-9757-608B9C21BBC4}"/>
+                <a16:creationId xmlns:a16="http://schemas.microsoft.com/office/drawing/2014/main" id="{71DF7FDF-69D0-44B4-A4E3-A954210F0230}"/>
               </a:ext>
             </a:extLst>
           </p:cNvPr>
@@ -1448,7 +1448,7 @@
     </p:spTree>
     <p:extLst>
       <p:ext uri="{BB962C8B-B14F-4D97-AF65-F5344CB8AC3E}">
-        <p14:creationId xmlns:p14="http://schemas.microsoft.com/office/powerpoint/2010/main" val="1598537934"/>
+        <p14:creationId xmlns:p14="http://schemas.microsoft.com/office/powerpoint/2010/main" val="439687885"/>
       </p:ext>
     </p:extLst>
   </p:cSld>

</xml_diff>

<commit_message>
Update cover member information
</commit_message>
<xml_diff>
--- a/Rent-Unfiltered-計畫書封面.pptx
+++ b/Rent-Unfiltered-計畫書封面.pptx
@@ -2,15 +2,15 @@
 <file path=ppt/presentation.xml><?xml version="1.0" encoding="utf-8"?>
 <p:presentation xmlns:p="http://schemas.openxmlformats.org/presentationml/2006/main">
   <p:sldMasterIdLst>
-    <p:sldMasterId xmlns:r="http://schemas.openxmlformats.org/officeDocument/2006/relationships" id="2147483648" r:id="Rb556939934c64680"/>
+    <p:sldMasterId xmlns:r="http://schemas.openxmlformats.org/officeDocument/2006/relationships" id="2147483648" r:id="R23324f35990b473b"/>
   </p:sldMasterIdLst>
   <p:notesMasterIdLst>
-    <p:notesMasterId xmlns:r="http://schemas.openxmlformats.org/officeDocument/2006/relationships" r:id="R64c3e7b80afe4523"/>
+    <p:notesMasterId xmlns:r="http://schemas.openxmlformats.org/officeDocument/2006/relationships" r:id="Rb9d6d3222db5409b"/>
   </p:notesMasterIdLst>
   <p:sldIdLst>
-    <p:sldId xmlns:r="http://schemas.openxmlformats.org/officeDocument/2006/relationships" id="256" r:id="R45d5bddd55ea45b6"/>
+    <p:sldId xmlns:r="http://schemas.openxmlformats.org/officeDocument/2006/relationships" id="256" r:id="R89a02df66a434aeb"/>
   </p:sldIdLst>
-  <p:sldSz cx="14630400" cy="9753600"/>
+  <p:sldSz cx="15925800" cy="8963025"/>
   <p:notesSz cx="6858000" cy="9144000"/>
   <p:defaultTextStyle>
     <a:defPPr xmlns:a="http://schemas.openxmlformats.org/drawingml/2006/main">
@@ -555,7 +555,7 @@
   </p:cSld>
   <p:clrMap bg1="lt1" tx1="dk1" bg2="lt2" tx2="dk2" accent1="accent1" accent2="accent2" accent3="accent3" accent4="accent4" accent5="accent5" accent6="accent6" hlink="hlink" folHlink="folHlink"/>
   <p:sldLayoutIdLst>
-    <p:sldLayoutId xmlns:r="http://schemas.openxmlformats.org/officeDocument/2006/relationships" id="2147483649" r:id="R93d9ca0fab444db5"/>
+    <p:sldLayoutId xmlns:r="http://schemas.openxmlformats.org/officeDocument/2006/relationships" id="2147483649" r:id="R888f624542de49ca"/>
   </p:sldLayoutIdLst>
   <p:txStyles>
     <p:titleStyle>
@@ -858,7 +858,7 @@
           <p:nvPr/>
         </p:nvPicPr>
         <p:blipFill>
-          <a:blip xmlns:r="http://schemas.openxmlformats.org/officeDocument/2006/relationships" xmlns:a="http://schemas.openxmlformats.org/drawingml/2006/main" r:embed="Rfc3b112e813c4e31"/>
+          <a:blip xmlns:r="http://schemas.openxmlformats.org/officeDocument/2006/relationships" xmlns:a="http://schemas.openxmlformats.org/drawingml/2006/main" r:embed="R2153006ff41f4071"/>
           <a:srcRect xmlns:a="http://schemas.openxmlformats.org/drawingml/2006/main" l="0" t="0" r="0" b="0"/>
           <a:stretch xmlns:a="http://schemas.openxmlformats.org/drawingml/2006/main">
             <a:fillRect l="0" t="0" r="0" b="0"/>
@@ -867,7 +867,7 @@
         <p:spPr>
           <a:xfrm xmlns:a="http://schemas.openxmlformats.org/drawingml/2006/main">
             <a:off x="0" y="0"/>
-            <a:ext cx="14630400" cy="9753600"/>
+            <a:ext cx="15925800" cy="8963025"/>
           </a:xfrm>
           <a:prstGeom xmlns:a="http://schemas.openxmlformats.org/drawingml/2006/main" prst="rect">
             <a:avLst/>
@@ -876,10 +876,10 @@
       </p:pic>
       <p:sp>
         <p:nvSpPr>
-          <p:cNvPr id="2" name="title-projection-panel">
+          <p:cNvPr id="2" name="member-info-clean-mask">
             <a:extLst xmlns:a="http://schemas.openxmlformats.org/drawingml/2006/main">
               <a:ext uri="{FF2B5EF4-FFF2-40B4-BE49-F238E27FC236}">
-                <a16:creationId xmlns:a16="http://schemas.microsoft.com/office/drawing/2014/main" id="{6F6F48C6-917B-4BF3-B41A-DA8CFC9FDCA8}"/>
+                <a16:creationId xmlns:a16="http://schemas.microsoft.com/office/drawing/2014/main" id="{B1C975DE-602E-45A4-87D5-60F5558A6CEA}"/>
               </a:ext>
             </a:extLst>
           </p:cNvPr>
@@ -890,21 +890,21 @@
         </p:nvSpPr>
         <p:spPr>
           <a:xfrm xmlns:a="http://schemas.openxmlformats.org/drawingml/2006/main">
-            <a:off x="2628900" y="781050"/>
-            <a:ext cx="9372600" cy="2209800"/>
+            <a:off x="12325350" y="7639050"/>
+            <a:ext cx="3238500" cy="1162050"/>
           </a:xfrm>
           <a:prstGeom xmlns:a="http://schemas.openxmlformats.org/drawingml/2006/main" prst="rect">
             <a:avLst/>
           </a:prstGeom>
           <a:solidFill xmlns:a="http://schemas.openxmlformats.org/drawingml/2006/main">
-            <a:srgbClr val="F8FBFF">
-              <a:alpha val="25882"/>
+            <a:srgbClr val="F2F8FC">
+              <a:alpha val="100000"/>
             </a:srgbClr>
           </a:solidFill>
-          <a:ln xmlns:a="http://schemas.openxmlformats.org/drawingml/2006/main" w="4763">
+          <a:ln xmlns:a="http://schemas.openxmlformats.org/drawingml/2006/main" w="7620">
             <a:solidFill>
-              <a:srgbClr val="C7DDF0">
-                <a:alpha val="14902"/>
+              <a:srgbClr val="9FC4E3">
+                <a:alpha val="40000"/>
               </a:srgbClr>
             </a:solidFill>
             <a:prstDash val="solid"/>
@@ -913,10 +913,10 @@
       </p:sp>
       <p:sp>
         <p:nvSpPr>
-          <p:cNvPr id="3" name="project-title-en">
+          <p:cNvPr id="3" name="members-label">
             <a:extLst xmlns:a="http://schemas.openxmlformats.org/drawingml/2006/main">
               <a:ext uri="{FF2B5EF4-FFF2-40B4-BE49-F238E27FC236}">
-                <a16:creationId xmlns:a16="http://schemas.microsoft.com/office/drawing/2014/main" id="{59E039B1-4D07-4181-A667-FD05838EF37D}"/>
+                <a16:creationId xmlns:a16="http://schemas.microsoft.com/office/drawing/2014/main" id="{F42D8E10-1ED9-41A0-953E-CBD6EA1825C2}"/>
               </a:ext>
             </a:extLst>
           </p:cNvPr>
@@ -927,414 +927,8 @@
         </p:nvSpPr>
         <p:spPr>
           <a:xfrm xmlns:a="http://schemas.openxmlformats.org/drawingml/2006/main">
-            <a:off x="2914650" y="1066800"/>
-            <a:ext cx="8801100" cy="628650"/>
-          </a:xfrm>
-          <a:prstGeom xmlns:a="http://schemas.openxmlformats.org/drawingml/2006/main" prst="rect">
-            <a:avLst/>
-          </a:prstGeom>
-          <a:solidFill xmlns:a="http://schemas.openxmlformats.org/drawingml/2006/main">
-            <a:srgbClr val="000000">
-              <a:alpha val="0"/>
-            </a:srgbClr>
-          </a:solidFill>
-          <a:ln xmlns:a="http://schemas.openxmlformats.org/drawingml/2006/main" w="0">
-            <a:solidFill>
-              <a:srgbClr val="000000">
-                <a:alpha val="0"/>
-              </a:srgbClr>
-            </a:solidFill>
-            <a:prstDash val="solid"/>
-          </a:ln>
-        </p:spPr>
-        <p:txBody>
-          <a:bodyPr xmlns:a="http://schemas.openxmlformats.org/drawingml/2006/main" lIns="0" tIns="0" rIns="0" bIns="0" anchor="t"/>
-          <a:lstStyle xmlns:a="http://schemas.openxmlformats.org/drawingml/2006/main"/>
-          <a:p xmlns:a="http://schemas.openxmlformats.org/drawingml/2006/main">
-            <a:pPr algn="ctr">
-              <a:defRPr sz="3450" b="1">
-                <a:solidFill>
-                  <a:srgbClr val="123557"/>
-                </a:solidFill>
-                <a:latin typeface="Aptos Display"/>
-                <a:ea typeface="Aptos Display"/>
-                <a:cs typeface="Aptos Display"/>
-              </a:defRPr>
-            </a:pPr>
-            <a:r>
-              <a:rPr sz="3450" b="1">
-                <a:solidFill>
-                  <a:srgbClr val="123557"/>
-                </a:solidFill>
-                <a:latin typeface="Aptos Display"/>
-                <a:ea typeface="Aptos Display"/>
-                <a:cs typeface="Aptos Display"/>
-              </a:rPr>
-              <a:t>Rent Unfiltered</a:t>
-            </a:r>
-          </a:p>
-        </p:txBody>
-      </p:sp>
-      <p:sp>
-        <p:nvSpPr>
-          <p:cNvPr id="4" name="project-title-zh">
-            <a:extLst xmlns:a="http://schemas.openxmlformats.org/drawingml/2006/main">
-              <a:ext uri="{FF2B5EF4-FFF2-40B4-BE49-F238E27FC236}">
-                <a16:creationId xmlns:a16="http://schemas.microsoft.com/office/drawing/2014/main" id="{782C8E4A-62F8-4E62-8E47-41EE80031473}"/>
-              </a:ext>
-            </a:extLst>
-          </p:cNvPr>
-          <p:cNvSpPr>
-            <a:spLocks xmlns:a="http://schemas.openxmlformats.org/drawingml/2006/main" noGrp="1"/>
-          </p:cNvSpPr>
-          <p:nvPr/>
-        </p:nvSpPr>
-        <p:spPr>
-          <a:xfrm xmlns:a="http://schemas.openxmlformats.org/drawingml/2006/main">
-            <a:off x="2914650" y="1638300"/>
-            <a:ext cx="8801100" cy="819150"/>
-          </a:xfrm>
-          <a:prstGeom xmlns:a="http://schemas.openxmlformats.org/drawingml/2006/main" prst="rect">
-            <a:avLst/>
-          </a:prstGeom>
-          <a:solidFill xmlns:a="http://schemas.openxmlformats.org/drawingml/2006/main">
-            <a:srgbClr val="000000">
-              <a:alpha val="0"/>
-            </a:srgbClr>
-          </a:solidFill>
-          <a:ln xmlns:a="http://schemas.openxmlformats.org/drawingml/2006/main" w="0">
-            <a:solidFill>
-              <a:srgbClr val="000000">
-                <a:alpha val="0"/>
-              </a:srgbClr>
-            </a:solidFill>
-            <a:prstDash val="solid"/>
-          </a:ln>
-        </p:spPr>
-        <p:txBody>
-          <a:bodyPr xmlns:a="http://schemas.openxmlformats.org/drawingml/2006/main" lIns="0" tIns="0" rIns="0" bIns="0" anchor="t"/>
-          <a:lstStyle xmlns:a="http://schemas.openxmlformats.org/drawingml/2006/main"/>
-          <a:p xmlns:a="http://schemas.openxmlformats.org/drawingml/2006/main">
-            <a:pPr algn="ctr">
-              <a:defRPr sz="4650" b="1">
-                <a:solidFill>
-                  <a:srgbClr val="082A47"/>
-                </a:solidFill>
-                <a:latin typeface="Microsoft JhengHei"/>
-                <a:ea typeface="Microsoft JhengHei"/>
-                <a:cs typeface="Microsoft JhengHei"/>
-              </a:defRPr>
-            </a:pPr>
-            <a:r>
-              <a:rPr sz="4650" b="1">
-                <a:solidFill>
-                  <a:srgbClr val="082A47"/>
-                </a:solidFill>
-                <a:latin typeface="Microsoft JhengHei"/>
-                <a:ea typeface="Microsoft JhengHei"/>
-                <a:cs typeface="Microsoft JhengHei"/>
-              </a:rPr>
-              <a:t>透明租屋</a:t>
-            </a:r>
-          </a:p>
-        </p:txBody>
-      </p:sp>
-      <p:sp>
-        <p:nvSpPr>
-          <p:cNvPr id="5" name="cover-slogan">
-            <a:extLst xmlns:a="http://schemas.openxmlformats.org/drawingml/2006/main">
-              <a:ext uri="{FF2B5EF4-FFF2-40B4-BE49-F238E27FC236}">
-                <a16:creationId xmlns:a16="http://schemas.microsoft.com/office/drawing/2014/main" id="{ACE3795A-A99B-47A6-81AB-42782130BC81}"/>
-              </a:ext>
-            </a:extLst>
-          </p:cNvPr>
-          <p:cNvSpPr>
-            <a:spLocks xmlns:a="http://schemas.openxmlformats.org/drawingml/2006/main" noGrp="1"/>
-          </p:cNvSpPr>
-          <p:nvPr/>
-        </p:nvSpPr>
-        <p:spPr>
-          <a:xfrm xmlns:a="http://schemas.openxmlformats.org/drawingml/2006/main">
-            <a:off x="3105150" y="2457450"/>
-            <a:ext cx="8420100" cy="342900"/>
-          </a:xfrm>
-          <a:prstGeom xmlns:a="http://schemas.openxmlformats.org/drawingml/2006/main" prst="rect">
-            <a:avLst/>
-          </a:prstGeom>
-          <a:solidFill xmlns:a="http://schemas.openxmlformats.org/drawingml/2006/main">
-            <a:srgbClr val="000000">
-              <a:alpha val="0"/>
-            </a:srgbClr>
-          </a:solidFill>
-          <a:ln xmlns:a="http://schemas.openxmlformats.org/drawingml/2006/main" w="0">
-            <a:solidFill>
-              <a:srgbClr val="000000">
-                <a:alpha val="0"/>
-              </a:srgbClr>
-            </a:solidFill>
-            <a:prstDash val="solid"/>
-          </a:ln>
-        </p:spPr>
-        <p:txBody>
-          <a:bodyPr xmlns:a="http://schemas.openxmlformats.org/drawingml/2006/main" lIns="0" tIns="0" rIns="0" bIns="0" anchor="t"/>
-          <a:lstStyle xmlns:a="http://schemas.openxmlformats.org/drawingml/2006/main"/>
-          <a:p xmlns:a="http://schemas.openxmlformats.org/drawingml/2006/main">
-            <a:pPr algn="ctr">
-              <a:defRPr sz="1575" b="0">
-                <a:solidFill>
-                  <a:srgbClr val="173E5F">
-                    <a:alpha val="93333"/>
-                  </a:srgbClr>
-                </a:solidFill>
-                <a:latin typeface="Microsoft JhengHei"/>
-                <a:ea typeface="Microsoft JhengHei"/>
-                <a:cs typeface="Microsoft JhengHei"/>
-              </a:defRPr>
-            </a:pPr>
-            <a:r>
-              <a:rPr sz="1575" b="0">
-                <a:solidFill>
-                  <a:srgbClr val="173E5F">
-                    <a:alpha val="93333"/>
-                  </a:srgbClr>
-                </a:solidFill>
-                <a:latin typeface="Microsoft JhengHei"/>
-                <a:ea typeface="Microsoft JhengHei"/>
-                <a:cs typeface="Microsoft JhengHei"/>
-              </a:rPr>
-              <a:t>讓租屋資訊，從廣告走向透明。</a:t>
-            </a:r>
-          </a:p>
-        </p:txBody>
-      </p:sp>
-      <p:sp>
-        <p:nvSpPr>
-          <p:cNvPr id="6" name="team-name-soft-fire-panel">
-            <a:extLst xmlns:a="http://schemas.openxmlformats.org/drawingml/2006/main">
-              <a:ext uri="{FF2B5EF4-FFF2-40B4-BE49-F238E27FC236}">
-                <a16:creationId xmlns:a16="http://schemas.microsoft.com/office/drawing/2014/main" id="{16494DEC-87A4-4452-8D1A-D0D774031CC7}"/>
-              </a:ext>
-            </a:extLst>
-          </p:cNvPr>
-          <p:cNvSpPr>
-            <a:spLocks xmlns:a="http://schemas.openxmlformats.org/drawingml/2006/main" noGrp="1"/>
-          </p:cNvSpPr>
-          <p:nvPr/>
-        </p:nvSpPr>
-        <p:spPr>
-          <a:xfrm xmlns:a="http://schemas.openxmlformats.org/drawingml/2006/main">
-            <a:off x="4724400" y="7800975"/>
-            <a:ext cx="5181600" cy="495300"/>
-          </a:xfrm>
-          <a:prstGeom xmlns:a="http://schemas.openxmlformats.org/drawingml/2006/main" prst="rect">
-            <a:avLst/>
-          </a:prstGeom>
-          <a:solidFill xmlns:a="http://schemas.openxmlformats.org/drawingml/2006/main">
-            <a:srgbClr val="FFF1BD">
-              <a:alpha val="21961"/>
-            </a:srgbClr>
-          </a:solidFill>
-          <a:ln xmlns:a="http://schemas.openxmlformats.org/drawingml/2006/main" w="4763">
-            <a:solidFill>
-              <a:srgbClr val="F4C56A">
-                <a:alpha val="13333"/>
-              </a:srgbClr>
-            </a:solidFill>
-            <a:prstDash val="solid"/>
-          </a:ln>
-        </p:spPr>
-      </p:sp>
-      <p:sp>
-        <p:nvSpPr>
-          <p:cNvPr id="7" name="team-name-warm-glow">
-            <a:extLst xmlns:a="http://schemas.openxmlformats.org/drawingml/2006/main">
-              <a:ext uri="{FF2B5EF4-FFF2-40B4-BE49-F238E27FC236}">
-                <a16:creationId xmlns:a16="http://schemas.microsoft.com/office/drawing/2014/main" id="{8D57F766-B207-4A59-A32A-4BD6300F6320}"/>
-              </a:ext>
-            </a:extLst>
-          </p:cNvPr>
-          <p:cNvSpPr>
-            <a:spLocks xmlns:a="http://schemas.openxmlformats.org/drawingml/2006/main" noGrp="1"/>
-          </p:cNvSpPr>
-          <p:nvPr/>
-        </p:nvSpPr>
-        <p:spPr>
-          <a:xfrm xmlns:a="http://schemas.openxmlformats.org/drawingml/2006/main">
-            <a:off x="4533900" y="7839075"/>
-            <a:ext cx="5562600" cy="419100"/>
-          </a:xfrm>
-          <a:prstGeom xmlns:a="http://schemas.openxmlformats.org/drawingml/2006/main" prst="rect">
-            <a:avLst/>
-          </a:prstGeom>
-          <a:solidFill xmlns:a="http://schemas.openxmlformats.org/drawingml/2006/main">
-            <a:srgbClr val="000000">
-              <a:alpha val="0"/>
-            </a:srgbClr>
-          </a:solidFill>
-          <a:ln xmlns:a="http://schemas.openxmlformats.org/drawingml/2006/main" w="0">
-            <a:solidFill>
-              <a:srgbClr val="000000">
-                <a:alpha val="0"/>
-              </a:srgbClr>
-            </a:solidFill>
-            <a:prstDash val="solid"/>
-          </a:ln>
-        </p:spPr>
-        <p:txBody>
-          <a:bodyPr xmlns:a="http://schemas.openxmlformats.org/drawingml/2006/main" lIns="0" tIns="0" rIns="0" bIns="0" anchor="t"/>
-          <a:lstStyle xmlns:a="http://schemas.openxmlformats.org/drawingml/2006/main"/>
-          <a:p xmlns:a="http://schemas.openxmlformats.org/drawingml/2006/main">
-            <a:pPr algn="ctr">
-              <a:defRPr sz="1875" b="0">
-                <a:solidFill>
-                  <a:srgbClr val="FFDFAE">
-                    <a:alpha val="53333"/>
-                  </a:srgbClr>
-                </a:solidFill>
-                <a:latin typeface="Microsoft JhengHei"/>
-                <a:ea typeface="Microsoft JhengHei"/>
-                <a:cs typeface="Microsoft JhengHei"/>
-              </a:defRPr>
-            </a:pPr>
-            <a:r>
-              <a:rPr sz="1875" b="0">
-                <a:solidFill>
-                  <a:srgbClr val="FFDFAE">
-                    <a:alpha val="53333"/>
-                  </a:srgbClr>
-                </a:solidFill>
-                <a:latin typeface="Microsoft JhengHei"/>
-                <a:ea typeface="Microsoft JhengHei"/>
-                <a:cs typeface="Microsoft JhengHei"/>
-              </a:rPr>
-              <a:t>不 動 業 火 笙 聲 生 不 熄</a:t>
-            </a:r>
-          </a:p>
-        </p:txBody>
-      </p:sp>
-      <p:sp>
-        <p:nvSpPr>
-          <p:cNvPr id="8" name="team-name">
-            <a:extLst xmlns:a="http://schemas.openxmlformats.org/drawingml/2006/main">
-              <a:ext uri="{FF2B5EF4-FFF2-40B4-BE49-F238E27FC236}">
-                <a16:creationId xmlns:a16="http://schemas.microsoft.com/office/drawing/2014/main" id="{3E964731-D54C-4731-AF9E-4731EDD99872}"/>
-              </a:ext>
-            </a:extLst>
-          </p:cNvPr>
-          <p:cNvSpPr>
-            <a:spLocks xmlns:a="http://schemas.openxmlformats.org/drawingml/2006/main" noGrp="1"/>
-          </p:cNvSpPr>
-          <p:nvPr/>
-        </p:nvSpPr>
-        <p:spPr>
-          <a:xfrm xmlns:a="http://schemas.openxmlformats.org/drawingml/2006/main">
-            <a:off x="4533900" y="7867650"/>
-            <a:ext cx="5562600" cy="400050"/>
-          </a:xfrm>
-          <a:prstGeom xmlns:a="http://schemas.openxmlformats.org/drawingml/2006/main" prst="rect">
-            <a:avLst/>
-          </a:prstGeom>
-          <a:solidFill xmlns:a="http://schemas.openxmlformats.org/drawingml/2006/main">
-            <a:srgbClr val="000000">
-              <a:alpha val="0"/>
-            </a:srgbClr>
-          </a:solidFill>
-          <a:ln xmlns:a="http://schemas.openxmlformats.org/drawingml/2006/main" w="0">
-            <a:solidFill>
-              <a:srgbClr val="000000">
-                <a:alpha val="0"/>
-              </a:srgbClr>
-            </a:solidFill>
-            <a:prstDash val="solid"/>
-          </a:ln>
-        </p:spPr>
-        <p:txBody>
-          <a:bodyPr xmlns:a="http://schemas.openxmlformats.org/drawingml/2006/main" lIns="0" tIns="0" rIns="0" bIns="0" anchor="t"/>
-          <a:lstStyle xmlns:a="http://schemas.openxmlformats.org/drawingml/2006/main"/>
-          <a:p xmlns:a="http://schemas.openxmlformats.org/drawingml/2006/main">
-            <a:pPr algn="ctr">
-              <a:defRPr sz="1875" b="0">
-                <a:solidFill>
-                  <a:srgbClr val="4A3929">
-                    <a:alpha val="86667"/>
-                  </a:srgbClr>
-                </a:solidFill>
-                <a:latin typeface="Microsoft JhengHei"/>
-                <a:ea typeface="Microsoft JhengHei"/>
-                <a:cs typeface="Microsoft JhengHei"/>
-              </a:defRPr>
-            </a:pPr>
-            <a:r>
-              <a:rPr sz="1875" b="0">
-                <a:solidFill>
-                  <a:srgbClr val="4A3929">
-                    <a:alpha val="86667"/>
-                  </a:srgbClr>
-                </a:solidFill>
-                <a:latin typeface="Microsoft JhengHei"/>
-                <a:ea typeface="Microsoft JhengHei"/>
-                <a:cs typeface="Microsoft JhengHei"/>
-              </a:rPr>
-              <a:t>不 動 業 火 笙 聲 生 不 熄</a:t>
-            </a:r>
-          </a:p>
-        </p:txBody>
-      </p:sp>
-      <p:sp>
-        <p:nvSpPr>
-          <p:cNvPr id="9" name="members-panel">
-            <a:extLst xmlns:a="http://schemas.openxmlformats.org/drawingml/2006/main">
-              <a:ext uri="{FF2B5EF4-FFF2-40B4-BE49-F238E27FC236}">
-                <a16:creationId xmlns:a16="http://schemas.microsoft.com/office/drawing/2014/main" id="{BFA480EC-3CD3-4000-BE47-09877F60F291}"/>
-              </a:ext>
-            </a:extLst>
-          </p:cNvPr>
-          <p:cNvSpPr>
-            <a:spLocks xmlns:a="http://schemas.openxmlformats.org/drawingml/2006/main" noGrp="1"/>
-          </p:cNvSpPr>
-          <p:nvPr/>
-        </p:nvSpPr>
-        <p:spPr>
-          <a:xfrm xmlns:a="http://schemas.openxmlformats.org/drawingml/2006/main">
-            <a:off x="10572750" y="8420100"/>
-            <a:ext cx="3276600" cy="742950"/>
-          </a:xfrm>
-          <a:prstGeom xmlns:a="http://schemas.openxmlformats.org/drawingml/2006/main" prst="rect">
-            <a:avLst/>
-          </a:prstGeom>
-          <a:solidFill xmlns:a="http://schemas.openxmlformats.org/drawingml/2006/main">
-            <a:srgbClr val="F7FBFF">
-              <a:alpha val="69020"/>
-            </a:srgbClr>
-          </a:solidFill>
-          <a:ln xmlns:a="http://schemas.openxmlformats.org/drawingml/2006/main" w="7620">
-            <a:solidFill>
-              <a:srgbClr val="8AB8E6">
-                <a:alpha val="26667"/>
-              </a:srgbClr>
-            </a:solidFill>
-            <a:prstDash val="solid"/>
-          </a:ln>
-        </p:spPr>
-      </p:sp>
-      <p:sp>
-        <p:nvSpPr>
-          <p:cNvPr id="10" name="members-label">
-            <a:extLst xmlns:a="http://schemas.openxmlformats.org/drawingml/2006/main">
-              <a:ext uri="{FF2B5EF4-FFF2-40B4-BE49-F238E27FC236}">
-                <a16:creationId xmlns:a16="http://schemas.microsoft.com/office/drawing/2014/main" id="{09434C0F-8785-476D-884A-F68336BC3320}"/>
-              </a:ext>
-            </a:extLst>
-          </p:cNvPr>
-          <p:cNvSpPr>
-            <a:spLocks xmlns:a="http://schemas.openxmlformats.org/drawingml/2006/main" noGrp="1"/>
-          </p:cNvSpPr>
-          <p:nvPr/>
-        </p:nvSpPr>
-        <p:spPr>
-          <a:xfrm xmlns:a="http://schemas.openxmlformats.org/drawingml/2006/main">
-            <a:off x="10782300" y="8534400"/>
-            <a:ext cx="2857500" cy="228600"/>
+            <a:off x="12573000" y="7772400"/>
+            <a:ext cx="2724150" cy="190500"/>
           </a:xfrm>
           <a:prstGeom xmlns:a="http://schemas.openxmlformats.org/drawingml/2006/main" prst="rect">
             <a:avLst/>
@@ -1358,9 +952,9 @@
           <a:lstStyle xmlns:a="http://schemas.openxmlformats.org/drawingml/2006/main"/>
           <a:p xmlns:a="http://schemas.openxmlformats.org/drawingml/2006/main">
             <a:pPr algn="r">
-              <a:defRPr sz="1050" b="0">
+              <a:defRPr sz="975" b="0">
                 <a:solidFill>
-                  <a:srgbClr val="4E6A82"/>
+                  <a:srgbClr val="315978"/>
                 </a:solidFill>
                 <a:latin typeface="Aptos"/>
                 <a:ea typeface="Aptos"/>
@@ -1368,9 +962,9 @@
               </a:defRPr>
             </a:pPr>
             <a:r>
-              <a:rPr sz="1050" b="0">
+              <a:rPr sz="975" b="0">
                 <a:solidFill>
-                  <a:srgbClr val="4E6A82"/>
+                  <a:srgbClr val="315978"/>
                 </a:solidFill>
                 <a:latin typeface="Aptos"/>
                 <a:ea typeface="Aptos"/>
@@ -1383,10 +977,10 @@
       </p:sp>
       <p:sp>
         <p:nvSpPr>
-          <p:cNvPr id="11" name="members-names">
+          <p:cNvPr id="4" name="member-one">
             <a:extLst xmlns:a="http://schemas.openxmlformats.org/drawingml/2006/main">
               <a:ext uri="{FF2B5EF4-FFF2-40B4-BE49-F238E27FC236}">
-                <a16:creationId xmlns:a16="http://schemas.microsoft.com/office/drawing/2014/main" id="{26D35E18-036F-464A-9533-0EEBF16CA74D}"/>
+                <a16:creationId xmlns:a16="http://schemas.microsoft.com/office/drawing/2014/main" id="{0FAA4C1A-FD80-4ED3-9890-E04EEA4950B2}"/>
               </a:ext>
             </a:extLst>
           </p:cNvPr>
@@ -1397,8 +991,8 @@
         </p:nvSpPr>
         <p:spPr>
           <a:xfrm xmlns:a="http://schemas.openxmlformats.org/drawingml/2006/main">
-            <a:off x="10782300" y="8782050"/>
-            <a:ext cx="2857500" cy="285750"/>
+            <a:off x="12496800" y="8058150"/>
+            <a:ext cx="2800350" cy="228600"/>
           </a:xfrm>
           <a:prstGeom xmlns:a="http://schemas.openxmlformats.org/drawingml/2006/main" prst="rect">
             <a:avLst/>
@@ -1422,9 +1016,9 @@
           <a:lstStyle xmlns:a="http://schemas.openxmlformats.org/drawingml/2006/main"/>
           <a:p xmlns:a="http://schemas.openxmlformats.org/drawingml/2006/main">
             <a:pPr algn="r">
-              <a:defRPr sz="1425" b="0">
+              <a:defRPr sz="1125" b="0">
                 <a:solidFill>
-                  <a:srgbClr val="213B55"/>
+                  <a:srgbClr val="102F4A"/>
                 </a:solidFill>
                 <a:latin typeface="Microsoft JhengHei"/>
                 <a:ea typeface="Microsoft JhengHei"/>
@@ -1432,15 +1026,79 @@
               </a:defRPr>
             </a:pPr>
             <a:r>
-              <a:rPr sz="1425" b="0">
+              <a:rPr sz="1125" b="0">
                 <a:solidFill>
-                  <a:srgbClr val="213B55"/>
+                  <a:srgbClr val="102F4A"/>
                 </a:solidFill>
                 <a:latin typeface="Microsoft JhengHei"/>
                 <a:ea typeface="Microsoft JhengHei"/>
                 <a:cs typeface="Microsoft JhengHei"/>
               </a:rPr>
-              <a:t>閻星澄｜羅士桓</a:t>
+              <a:t>閻星澄｜財務管理學系一年級</a:t>
+            </a:r>
+          </a:p>
+        </p:txBody>
+      </p:sp>
+      <p:sp>
+        <p:nvSpPr>
+          <p:cNvPr id="5" name="member-two">
+            <a:extLst xmlns:a="http://schemas.openxmlformats.org/drawingml/2006/main">
+              <a:ext uri="{FF2B5EF4-FFF2-40B4-BE49-F238E27FC236}">
+                <a16:creationId xmlns:a16="http://schemas.microsoft.com/office/drawing/2014/main" id="{38C0A2C4-4C34-43A3-8C23-4EEB848706FF}"/>
+              </a:ext>
+            </a:extLst>
+          </p:cNvPr>
+          <p:cNvSpPr>
+            <a:spLocks xmlns:a="http://schemas.openxmlformats.org/drawingml/2006/main" noGrp="1"/>
+          </p:cNvSpPr>
+          <p:nvPr/>
+        </p:nvSpPr>
+        <p:spPr>
+          <a:xfrm xmlns:a="http://schemas.openxmlformats.org/drawingml/2006/main">
+            <a:off x="12496800" y="8362950"/>
+            <a:ext cx="2800350" cy="228600"/>
+          </a:xfrm>
+          <a:prstGeom xmlns:a="http://schemas.openxmlformats.org/drawingml/2006/main" prst="rect">
+            <a:avLst/>
+          </a:prstGeom>
+          <a:solidFill xmlns:a="http://schemas.openxmlformats.org/drawingml/2006/main">
+            <a:srgbClr val="000000">
+              <a:alpha val="0"/>
+            </a:srgbClr>
+          </a:solidFill>
+          <a:ln xmlns:a="http://schemas.openxmlformats.org/drawingml/2006/main" w="0">
+            <a:solidFill>
+              <a:srgbClr val="000000">
+                <a:alpha val="0"/>
+              </a:srgbClr>
+            </a:solidFill>
+            <a:prstDash val="solid"/>
+          </a:ln>
+        </p:spPr>
+        <p:txBody>
+          <a:bodyPr xmlns:a="http://schemas.openxmlformats.org/drawingml/2006/main" lIns="0" tIns="0" rIns="0" bIns="0" anchor="t"/>
+          <a:lstStyle xmlns:a="http://schemas.openxmlformats.org/drawingml/2006/main"/>
+          <a:p xmlns:a="http://schemas.openxmlformats.org/drawingml/2006/main">
+            <a:pPr algn="r">
+              <a:defRPr sz="1125" b="0">
+                <a:solidFill>
+                  <a:srgbClr val="102F4A"/>
+                </a:solidFill>
+                <a:latin typeface="Microsoft JhengHei"/>
+                <a:ea typeface="Microsoft JhengHei"/>
+                <a:cs typeface="Microsoft JhengHei"/>
+              </a:defRPr>
+            </a:pPr>
+            <a:r>
+              <a:rPr sz="1125" b="0">
+                <a:solidFill>
+                  <a:srgbClr val="102F4A"/>
+                </a:solidFill>
+                <a:latin typeface="Microsoft JhengHei"/>
+                <a:ea typeface="Microsoft JhengHei"/>
+                <a:cs typeface="Microsoft JhengHei"/>
+              </a:rPr>
+              <a:t>羅士桓｜經濟學系一年級</a:t>
             </a:r>
           </a:p>
         </p:txBody>
@@ -1448,7 +1106,7 @@
     </p:spTree>
     <p:extLst>
       <p:ext uri="{BB962C8B-B14F-4D97-AF65-F5344CB8AC3E}">
-        <p14:creationId xmlns:p14="http://schemas.microsoft.com/office/powerpoint/2010/main" val="654678743"/>
+        <p14:creationId xmlns:p14="http://schemas.microsoft.com/office/powerpoint/2010/main" val="759086781"/>
       </p:ext>
     </p:extLst>
   </p:cSld>

</xml_diff>